<commit_message>
Audit Chapter 1 submission provenance and clean publication handover
</commit_message>
<xml_diff>
--- a/outputs/publication/figure_sources/Figures_1_2_editable_source.pptx
+++ b/outputs/publication/figure_sources/Figures_1_2_editable_source.pptx
@@ -262,7 +262,7 @@
           <a:p>
             <a:fld id="{3DCE47AA-BFA2-4964-A603-3EC927EB72AF}" type="datetimeFigureOut">
               <a:rPr lang="en-NL" smtClean="0"/>
-              <a:t>26/06/2026</a:t>
+              <a:t>09/08/2026</a:t>
             </a:fld>
             <a:endParaRPr lang="en-NL"/>
           </a:p>
@@ -462,7 +462,7 @@
           <a:p>
             <a:fld id="{3DCE47AA-BFA2-4964-A603-3EC927EB72AF}" type="datetimeFigureOut">
               <a:rPr lang="en-NL" smtClean="0"/>
-              <a:t>26/06/2026</a:t>
+              <a:t>09/08/2026</a:t>
             </a:fld>
             <a:endParaRPr lang="en-NL"/>
           </a:p>
@@ -672,7 +672,7 @@
           <a:p>
             <a:fld id="{3DCE47AA-BFA2-4964-A603-3EC927EB72AF}" type="datetimeFigureOut">
               <a:rPr lang="en-NL" smtClean="0"/>
-              <a:t>26/06/2026</a:t>
+              <a:t>09/08/2026</a:t>
             </a:fld>
             <a:endParaRPr lang="en-NL"/>
           </a:p>
@@ -872,7 +872,7 @@
           <a:p>
             <a:fld id="{3DCE47AA-BFA2-4964-A603-3EC927EB72AF}" type="datetimeFigureOut">
               <a:rPr lang="en-NL" smtClean="0"/>
-              <a:t>26/06/2026</a:t>
+              <a:t>09/08/2026</a:t>
             </a:fld>
             <a:endParaRPr lang="en-NL"/>
           </a:p>
@@ -1148,7 +1148,7 @@
           <a:p>
             <a:fld id="{3DCE47AA-BFA2-4964-A603-3EC927EB72AF}" type="datetimeFigureOut">
               <a:rPr lang="en-NL" smtClean="0"/>
-              <a:t>26/06/2026</a:t>
+              <a:t>09/08/2026</a:t>
             </a:fld>
             <a:endParaRPr lang="en-NL"/>
           </a:p>
@@ -1416,7 +1416,7 @@
           <a:p>
             <a:fld id="{3DCE47AA-BFA2-4964-A603-3EC927EB72AF}" type="datetimeFigureOut">
               <a:rPr lang="en-NL" smtClean="0"/>
-              <a:t>26/06/2026</a:t>
+              <a:t>09/08/2026</a:t>
             </a:fld>
             <a:endParaRPr lang="en-NL"/>
           </a:p>
@@ -1831,7 +1831,7 @@
           <a:p>
             <a:fld id="{3DCE47AA-BFA2-4964-A603-3EC927EB72AF}" type="datetimeFigureOut">
               <a:rPr lang="en-NL" smtClean="0"/>
-              <a:t>26/06/2026</a:t>
+              <a:t>09/08/2026</a:t>
             </a:fld>
             <a:endParaRPr lang="en-NL"/>
           </a:p>
@@ -1973,7 +1973,7 @@
           <a:p>
             <a:fld id="{3DCE47AA-BFA2-4964-A603-3EC927EB72AF}" type="datetimeFigureOut">
               <a:rPr lang="en-NL" smtClean="0"/>
-              <a:t>26/06/2026</a:t>
+              <a:t>09/08/2026</a:t>
             </a:fld>
             <a:endParaRPr lang="en-NL"/>
           </a:p>
@@ -2086,7 +2086,7 @@
           <a:p>
             <a:fld id="{3DCE47AA-BFA2-4964-A603-3EC927EB72AF}" type="datetimeFigureOut">
               <a:rPr lang="en-NL" smtClean="0"/>
-              <a:t>26/06/2026</a:t>
+              <a:t>09/08/2026</a:t>
             </a:fld>
             <a:endParaRPr lang="en-NL"/>
           </a:p>
@@ -2399,7 +2399,7 @@
           <a:p>
             <a:fld id="{3DCE47AA-BFA2-4964-A603-3EC927EB72AF}" type="datetimeFigureOut">
               <a:rPr lang="en-NL" smtClean="0"/>
-              <a:t>26/06/2026</a:t>
+              <a:t>09/08/2026</a:t>
             </a:fld>
             <a:endParaRPr lang="en-NL"/>
           </a:p>
@@ -2688,7 +2688,7 @@
           <a:p>
             <a:fld id="{3DCE47AA-BFA2-4964-A603-3EC927EB72AF}" type="datetimeFigureOut">
               <a:rPr lang="en-NL" smtClean="0"/>
-              <a:t>26/06/2026</a:t>
+              <a:t>09/08/2026</a:t>
             </a:fld>
             <a:endParaRPr lang="en-NL"/>
           </a:p>
@@ -2931,7 +2931,7 @@
           <a:p>
             <a:fld id="{3DCE47AA-BFA2-4964-A603-3EC927EB72AF}" type="datetimeFigureOut">
               <a:rPr lang="en-NL" smtClean="0"/>
-              <a:t>26/06/2026</a:t>
+              <a:t>09/08/2026</a:t>
             </a:fld>
             <a:endParaRPr lang="en-NL"/>
           </a:p>
@@ -5391,7 +5391,7 @@
         </p:nvSpPr>
         <p:spPr>
           <a:xfrm>
-            <a:off x="6175571" y="677732"/>
+            <a:off x="5776979" y="677732"/>
             <a:ext cx="1468419" cy="238074"/>
           </a:xfrm>
           <a:prstGeom prst="rect">
@@ -6955,1568 +6955,6 @@
         <p:spPr>
           <a:xfrm>
             <a:off x="4401671" y="6077215"/>
-            <a:ext cx="64546" cy="0"/>
-          </a:xfrm>
-          <a:prstGeom prst="line">
-            <a:avLst/>
-          </a:prstGeom>
-          <a:ln w="10160">
-            <a:solidFill>
-              <a:srgbClr val="252525"/>
-            </a:solidFill>
-          </a:ln>
-        </p:spPr>
-        <p:style>
-          <a:lnRef idx="2">
-            <a:schemeClr val="accent1"/>
-          </a:lnRef>
-          <a:fillRef idx="0">
-            <a:schemeClr val="accent1"/>
-          </a:fillRef>
-          <a:effectRef idx="1">
-            <a:schemeClr val="accent1"/>
-          </a:effectRef>
-          <a:fontRef idx="minor">
-            <a:schemeClr val="tx1"/>
-          </a:fontRef>
-        </p:style>
-      </p:cxnSp>
-      <p:sp>
-        <p:nvSpPr>
-          <p:cNvPr id="50" name="TextBox 49"/>
-          <p:cNvSpPr txBox="1"/>
-          <p:nvPr/>
-        </p:nvSpPr>
-        <p:spPr>
-          <a:xfrm>
-            <a:off x="5868978" y="990677"/>
-            <a:ext cx="338866" cy="161130"/>
-          </a:xfrm>
-          <a:prstGeom prst="rect">
-            <a:avLst/>
-          </a:prstGeom>
-          <a:noFill/>
-        </p:spPr>
-        <p:txBody>
-          <a:bodyPr wrap="square" lIns="22412" tIns="11206" rIns="22412" bIns="11206" anchor="ctr">
-            <a:spAutoFit/>
-          </a:bodyPr>
-          <a:lstStyle/>
-          <a:p>
-            <a:pPr algn="r"/>
-            <a:r>
-              <a:rPr sz="900">
-                <a:solidFill>
-                  <a:srgbClr val="111111"/>
-                </a:solidFill>
-                <a:latin typeface="Times New Roman" panose="02020603050405020304" pitchFamily="18" charset="0"/>
-                <a:cs typeface="Times New Roman" panose="02020603050405020304" pitchFamily="18" charset="0"/>
-              </a:rPr>
-              <a:t>2001</a:t>
-            </a:r>
-          </a:p>
-        </p:txBody>
-      </p:sp>
-      <p:cxnSp>
-        <p:nvCxnSpPr>
-          <p:cNvPr id="51" name="Connector 50"/>
-          <p:cNvCxnSpPr/>
-          <p:nvPr/>
-        </p:nvCxnSpPr>
-        <p:spPr>
-          <a:xfrm>
-            <a:off x="6191708" y="1071241"/>
-            <a:ext cx="64546" cy="0"/>
-          </a:xfrm>
-          <a:prstGeom prst="line">
-            <a:avLst/>
-          </a:prstGeom>
-          <a:ln w="10160">
-            <a:solidFill>
-              <a:srgbClr val="252525"/>
-            </a:solidFill>
-          </a:ln>
-        </p:spPr>
-        <p:style>
-          <a:lnRef idx="2">
-            <a:schemeClr val="accent1"/>
-          </a:lnRef>
-          <a:fillRef idx="0">
-            <a:schemeClr val="accent1"/>
-          </a:fillRef>
-          <a:effectRef idx="1">
-            <a:schemeClr val="accent1"/>
-          </a:effectRef>
-          <a:fontRef idx="minor">
-            <a:schemeClr val="tx1"/>
-          </a:fontRef>
-        </p:style>
-      </p:cxnSp>
-      <p:sp>
-        <p:nvSpPr>
-          <p:cNvPr id="52" name="TextBox 51"/>
-          <p:cNvSpPr txBox="1"/>
-          <p:nvPr/>
-        </p:nvSpPr>
-        <p:spPr>
-          <a:xfrm>
-            <a:off x="5868978" y="1229057"/>
-            <a:ext cx="338866" cy="161130"/>
-          </a:xfrm>
-          <a:prstGeom prst="rect">
-            <a:avLst/>
-          </a:prstGeom>
-          <a:noFill/>
-        </p:spPr>
-        <p:txBody>
-          <a:bodyPr wrap="square" lIns="22412" tIns="11206" rIns="22412" bIns="11206" anchor="ctr">
-            <a:spAutoFit/>
-          </a:bodyPr>
-          <a:lstStyle/>
-          <a:p>
-            <a:pPr algn="r"/>
-            <a:r>
-              <a:rPr sz="900">
-                <a:solidFill>
-                  <a:srgbClr val="111111"/>
-                </a:solidFill>
-                <a:latin typeface="Times New Roman" panose="02020603050405020304" pitchFamily="18" charset="0"/>
-                <a:cs typeface="Times New Roman" panose="02020603050405020304" pitchFamily="18" charset="0"/>
-              </a:rPr>
-              <a:t>2002</a:t>
-            </a:r>
-          </a:p>
-        </p:txBody>
-      </p:sp>
-      <p:cxnSp>
-        <p:nvCxnSpPr>
-          <p:cNvPr id="53" name="Connector 52"/>
-          <p:cNvCxnSpPr/>
-          <p:nvPr/>
-        </p:nvCxnSpPr>
-        <p:spPr>
-          <a:xfrm>
-            <a:off x="6191708" y="1309621"/>
-            <a:ext cx="64546" cy="0"/>
-          </a:xfrm>
-          <a:prstGeom prst="line">
-            <a:avLst/>
-          </a:prstGeom>
-          <a:ln w="10160">
-            <a:solidFill>
-              <a:srgbClr val="252525"/>
-            </a:solidFill>
-          </a:ln>
-        </p:spPr>
-        <p:style>
-          <a:lnRef idx="2">
-            <a:schemeClr val="accent1"/>
-          </a:lnRef>
-          <a:fillRef idx="0">
-            <a:schemeClr val="accent1"/>
-          </a:fillRef>
-          <a:effectRef idx="1">
-            <a:schemeClr val="accent1"/>
-          </a:effectRef>
-          <a:fontRef idx="minor">
-            <a:schemeClr val="tx1"/>
-          </a:fontRef>
-        </p:style>
-      </p:cxnSp>
-      <p:sp>
-        <p:nvSpPr>
-          <p:cNvPr id="54" name="TextBox 53"/>
-          <p:cNvSpPr txBox="1"/>
-          <p:nvPr/>
-        </p:nvSpPr>
-        <p:spPr>
-          <a:xfrm>
-            <a:off x="5868978" y="1467437"/>
-            <a:ext cx="338866" cy="161130"/>
-          </a:xfrm>
-          <a:prstGeom prst="rect">
-            <a:avLst/>
-          </a:prstGeom>
-          <a:noFill/>
-        </p:spPr>
-        <p:txBody>
-          <a:bodyPr wrap="square" lIns="22412" tIns="11206" rIns="22412" bIns="11206" anchor="ctr">
-            <a:spAutoFit/>
-          </a:bodyPr>
-          <a:lstStyle/>
-          <a:p>
-            <a:pPr algn="r"/>
-            <a:r>
-              <a:rPr sz="900">
-                <a:solidFill>
-                  <a:srgbClr val="111111"/>
-                </a:solidFill>
-                <a:latin typeface="Times New Roman" panose="02020603050405020304" pitchFamily="18" charset="0"/>
-                <a:cs typeface="Times New Roman" panose="02020603050405020304" pitchFamily="18" charset="0"/>
-              </a:rPr>
-              <a:t>2003</a:t>
-            </a:r>
-          </a:p>
-        </p:txBody>
-      </p:sp>
-      <p:cxnSp>
-        <p:nvCxnSpPr>
-          <p:cNvPr id="55" name="Connector 54"/>
-          <p:cNvCxnSpPr/>
-          <p:nvPr/>
-        </p:nvCxnSpPr>
-        <p:spPr>
-          <a:xfrm>
-            <a:off x="6191708" y="1548001"/>
-            <a:ext cx="64546" cy="0"/>
-          </a:xfrm>
-          <a:prstGeom prst="line">
-            <a:avLst/>
-          </a:prstGeom>
-          <a:ln w="10160">
-            <a:solidFill>
-              <a:srgbClr val="252525"/>
-            </a:solidFill>
-          </a:ln>
-        </p:spPr>
-        <p:style>
-          <a:lnRef idx="2">
-            <a:schemeClr val="accent1"/>
-          </a:lnRef>
-          <a:fillRef idx="0">
-            <a:schemeClr val="accent1"/>
-          </a:fillRef>
-          <a:effectRef idx="1">
-            <a:schemeClr val="accent1"/>
-          </a:effectRef>
-          <a:fontRef idx="minor">
-            <a:schemeClr val="tx1"/>
-          </a:fontRef>
-        </p:style>
-      </p:cxnSp>
-      <p:sp>
-        <p:nvSpPr>
-          <p:cNvPr id="56" name="TextBox 55"/>
-          <p:cNvSpPr txBox="1"/>
-          <p:nvPr/>
-        </p:nvSpPr>
-        <p:spPr>
-          <a:xfrm>
-            <a:off x="5868978" y="1705816"/>
-            <a:ext cx="338866" cy="161130"/>
-          </a:xfrm>
-          <a:prstGeom prst="rect">
-            <a:avLst/>
-          </a:prstGeom>
-          <a:noFill/>
-        </p:spPr>
-        <p:txBody>
-          <a:bodyPr wrap="square" lIns="22412" tIns="11206" rIns="22412" bIns="11206" anchor="ctr">
-            <a:spAutoFit/>
-          </a:bodyPr>
-          <a:lstStyle/>
-          <a:p>
-            <a:pPr algn="r"/>
-            <a:r>
-              <a:rPr sz="900">
-                <a:solidFill>
-                  <a:srgbClr val="111111"/>
-                </a:solidFill>
-                <a:latin typeface="Times New Roman" panose="02020603050405020304" pitchFamily="18" charset="0"/>
-                <a:cs typeface="Times New Roman" panose="02020603050405020304" pitchFamily="18" charset="0"/>
-              </a:rPr>
-              <a:t>2004</a:t>
-            </a:r>
-          </a:p>
-        </p:txBody>
-      </p:sp>
-      <p:cxnSp>
-        <p:nvCxnSpPr>
-          <p:cNvPr id="57" name="Connector 56"/>
-          <p:cNvCxnSpPr/>
-          <p:nvPr/>
-        </p:nvCxnSpPr>
-        <p:spPr>
-          <a:xfrm>
-            <a:off x="6191708" y="1786380"/>
-            <a:ext cx="64546" cy="0"/>
-          </a:xfrm>
-          <a:prstGeom prst="line">
-            <a:avLst/>
-          </a:prstGeom>
-          <a:ln w="10160">
-            <a:solidFill>
-              <a:srgbClr val="252525"/>
-            </a:solidFill>
-          </a:ln>
-        </p:spPr>
-        <p:style>
-          <a:lnRef idx="2">
-            <a:schemeClr val="accent1"/>
-          </a:lnRef>
-          <a:fillRef idx="0">
-            <a:schemeClr val="accent1"/>
-          </a:fillRef>
-          <a:effectRef idx="1">
-            <a:schemeClr val="accent1"/>
-          </a:effectRef>
-          <a:fontRef idx="minor">
-            <a:schemeClr val="tx1"/>
-          </a:fontRef>
-        </p:style>
-      </p:cxnSp>
-      <p:sp>
-        <p:nvSpPr>
-          <p:cNvPr id="58" name="TextBox 57"/>
-          <p:cNvSpPr txBox="1"/>
-          <p:nvPr/>
-        </p:nvSpPr>
-        <p:spPr>
-          <a:xfrm>
-            <a:off x="5868978" y="1944196"/>
-            <a:ext cx="338866" cy="161130"/>
-          </a:xfrm>
-          <a:prstGeom prst="rect">
-            <a:avLst/>
-          </a:prstGeom>
-          <a:noFill/>
-        </p:spPr>
-        <p:txBody>
-          <a:bodyPr wrap="square" lIns="22412" tIns="11206" rIns="22412" bIns="11206" anchor="ctr">
-            <a:spAutoFit/>
-          </a:bodyPr>
-          <a:lstStyle/>
-          <a:p>
-            <a:pPr algn="r"/>
-            <a:r>
-              <a:rPr sz="900">
-                <a:solidFill>
-                  <a:srgbClr val="111111"/>
-                </a:solidFill>
-                <a:latin typeface="Times New Roman" panose="02020603050405020304" pitchFamily="18" charset="0"/>
-                <a:cs typeface="Times New Roman" panose="02020603050405020304" pitchFamily="18" charset="0"/>
-              </a:rPr>
-              <a:t>2005</a:t>
-            </a:r>
-          </a:p>
-        </p:txBody>
-      </p:sp>
-      <p:cxnSp>
-        <p:nvCxnSpPr>
-          <p:cNvPr id="59" name="Connector 58"/>
-          <p:cNvCxnSpPr/>
-          <p:nvPr/>
-        </p:nvCxnSpPr>
-        <p:spPr>
-          <a:xfrm>
-            <a:off x="6191708" y="2024760"/>
-            <a:ext cx="64546" cy="0"/>
-          </a:xfrm>
-          <a:prstGeom prst="line">
-            <a:avLst/>
-          </a:prstGeom>
-          <a:ln w="10160">
-            <a:solidFill>
-              <a:srgbClr val="252525"/>
-            </a:solidFill>
-          </a:ln>
-        </p:spPr>
-        <p:style>
-          <a:lnRef idx="2">
-            <a:schemeClr val="accent1"/>
-          </a:lnRef>
-          <a:fillRef idx="0">
-            <a:schemeClr val="accent1"/>
-          </a:fillRef>
-          <a:effectRef idx="1">
-            <a:schemeClr val="accent1"/>
-          </a:effectRef>
-          <a:fontRef idx="minor">
-            <a:schemeClr val="tx1"/>
-          </a:fontRef>
-        </p:style>
-      </p:cxnSp>
-      <p:sp>
-        <p:nvSpPr>
-          <p:cNvPr id="60" name="TextBox 59"/>
-          <p:cNvSpPr txBox="1"/>
-          <p:nvPr/>
-        </p:nvSpPr>
-        <p:spPr>
-          <a:xfrm>
-            <a:off x="5868978" y="2182576"/>
-            <a:ext cx="338866" cy="161130"/>
-          </a:xfrm>
-          <a:prstGeom prst="rect">
-            <a:avLst/>
-          </a:prstGeom>
-          <a:noFill/>
-        </p:spPr>
-        <p:txBody>
-          <a:bodyPr wrap="square" lIns="22412" tIns="11206" rIns="22412" bIns="11206" anchor="ctr">
-            <a:spAutoFit/>
-          </a:bodyPr>
-          <a:lstStyle/>
-          <a:p>
-            <a:pPr algn="r"/>
-            <a:r>
-              <a:rPr sz="900">
-                <a:solidFill>
-                  <a:srgbClr val="111111"/>
-                </a:solidFill>
-                <a:latin typeface="Times New Roman" panose="02020603050405020304" pitchFamily="18" charset="0"/>
-                <a:cs typeface="Times New Roman" panose="02020603050405020304" pitchFamily="18" charset="0"/>
-              </a:rPr>
-              <a:t>2006</a:t>
-            </a:r>
-          </a:p>
-        </p:txBody>
-      </p:sp>
-      <p:cxnSp>
-        <p:nvCxnSpPr>
-          <p:cNvPr id="61" name="Connector 60"/>
-          <p:cNvCxnSpPr/>
-          <p:nvPr/>
-        </p:nvCxnSpPr>
-        <p:spPr>
-          <a:xfrm>
-            <a:off x="6191708" y="2263139"/>
-            <a:ext cx="64546" cy="0"/>
-          </a:xfrm>
-          <a:prstGeom prst="line">
-            <a:avLst/>
-          </a:prstGeom>
-          <a:ln w="10160">
-            <a:solidFill>
-              <a:srgbClr val="252525"/>
-            </a:solidFill>
-          </a:ln>
-        </p:spPr>
-        <p:style>
-          <a:lnRef idx="2">
-            <a:schemeClr val="accent1"/>
-          </a:lnRef>
-          <a:fillRef idx="0">
-            <a:schemeClr val="accent1"/>
-          </a:fillRef>
-          <a:effectRef idx="1">
-            <a:schemeClr val="accent1"/>
-          </a:effectRef>
-          <a:fontRef idx="minor">
-            <a:schemeClr val="tx1"/>
-          </a:fontRef>
-        </p:style>
-      </p:cxnSp>
-      <p:sp>
-        <p:nvSpPr>
-          <p:cNvPr id="62" name="TextBox 61"/>
-          <p:cNvSpPr txBox="1"/>
-          <p:nvPr/>
-        </p:nvSpPr>
-        <p:spPr>
-          <a:xfrm>
-            <a:off x="5868978" y="2420955"/>
-            <a:ext cx="338866" cy="161130"/>
-          </a:xfrm>
-          <a:prstGeom prst="rect">
-            <a:avLst/>
-          </a:prstGeom>
-          <a:noFill/>
-        </p:spPr>
-        <p:txBody>
-          <a:bodyPr wrap="square" lIns="22412" tIns="11206" rIns="22412" bIns="11206" anchor="ctr">
-            <a:spAutoFit/>
-          </a:bodyPr>
-          <a:lstStyle/>
-          <a:p>
-            <a:pPr algn="r"/>
-            <a:r>
-              <a:rPr sz="900">
-                <a:solidFill>
-                  <a:srgbClr val="111111"/>
-                </a:solidFill>
-                <a:latin typeface="Times New Roman" panose="02020603050405020304" pitchFamily="18" charset="0"/>
-                <a:cs typeface="Times New Roman" panose="02020603050405020304" pitchFamily="18" charset="0"/>
-              </a:rPr>
-              <a:t>2007</a:t>
-            </a:r>
-          </a:p>
-        </p:txBody>
-      </p:sp>
-      <p:cxnSp>
-        <p:nvCxnSpPr>
-          <p:cNvPr id="63" name="Connector 62"/>
-          <p:cNvCxnSpPr/>
-          <p:nvPr/>
-        </p:nvCxnSpPr>
-        <p:spPr>
-          <a:xfrm>
-            <a:off x="6191708" y="2501519"/>
-            <a:ext cx="64546" cy="0"/>
-          </a:xfrm>
-          <a:prstGeom prst="line">
-            <a:avLst/>
-          </a:prstGeom>
-          <a:ln w="10160">
-            <a:solidFill>
-              <a:srgbClr val="252525"/>
-            </a:solidFill>
-          </a:ln>
-        </p:spPr>
-        <p:style>
-          <a:lnRef idx="2">
-            <a:schemeClr val="accent1"/>
-          </a:lnRef>
-          <a:fillRef idx="0">
-            <a:schemeClr val="accent1"/>
-          </a:fillRef>
-          <a:effectRef idx="1">
-            <a:schemeClr val="accent1"/>
-          </a:effectRef>
-          <a:fontRef idx="minor">
-            <a:schemeClr val="tx1"/>
-          </a:fontRef>
-        </p:style>
-      </p:cxnSp>
-      <p:sp>
-        <p:nvSpPr>
-          <p:cNvPr id="64" name="TextBox 63"/>
-          <p:cNvSpPr txBox="1"/>
-          <p:nvPr/>
-        </p:nvSpPr>
-        <p:spPr>
-          <a:xfrm>
-            <a:off x="5868978" y="2659335"/>
-            <a:ext cx="338866" cy="161130"/>
-          </a:xfrm>
-          <a:prstGeom prst="rect">
-            <a:avLst/>
-          </a:prstGeom>
-          <a:noFill/>
-        </p:spPr>
-        <p:txBody>
-          <a:bodyPr wrap="square" lIns="22412" tIns="11206" rIns="22412" bIns="11206" anchor="ctr">
-            <a:spAutoFit/>
-          </a:bodyPr>
-          <a:lstStyle/>
-          <a:p>
-            <a:pPr algn="r"/>
-            <a:r>
-              <a:rPr sz="900">
-                <a:solidFill>
-                  <a:srgbClr val="111111"/>
-                </a:solidFill>
-                <a:latin typeface="Times New Roman" panose="02020603050405020304" pitchFamily="18" charset="0"/>
-                <a:cs typeface="Times New Roman" panose="02020603050405020304" pitchFamily="18" charset="0"/>
-              </a:rPr>
-              <a:t>2008</a:t>
-            </a:r>
-          </a:p>
-        </p:txBody>
-      </p:sp>
-      <p:cxnSp>
-        <p:nvCxnSpPr>
-          <p:cNvPr id="65" name="Connector 64"/>
-          <p:cNvCxnSpPr/>
-          <p:nvPr/>
-        </p:nvCxnSpPr>
-        <p:spPr>
-          <a:xfrm>
-            <a:off x="6191708" y="2739899"/>
-            <a:ext cx="64546" cy="0"/>
-          </a:xfrm>
-          <a:prstGeom prst="line">
-            <a:avLst/>
-          </a:prstGeom>
-          <a:ln w="10160">
-            <a:solidFill>
-              <a:srgbClr val="252525"/>
-            </a:solidFill>
-          </a:ln>
-        </p:spPr>
-        <p:style>
-          <a:lnRef idx="2">
-            <a:schemeClr val="accent1"/>
-          </a:lnRef>
-          <a:fillRef idx="0">
-            <a:schemeClr val="accent1"/>
-          </a:fillRef>
-          <a:effectRef idx="1">
-            <a:schemeClr val="accent1"/>
-          </a:effectRef>
-          <a:fontRef idx="minor">
-            <a:schemeClr val="tx1"/>
-          </a:fontRef>
-        </p:style>
-      </p:cxnSp>
-      <p:sp>
-        <p:nvSpPr>
-          <p:cNvPr id="66" name="TextBox 65"/>
-          <p:cNvSpPr txBox="1"/>
-          <p:nvPr/>
-        </p:nvSpPr>
-        <p:spPr>
-          <a:xfrm>
-            <a:off x="5868978" y="2897714"/>
-            <a:ext cx="338866" cy="161130"/>
-          </a:xfrm>
-          <a:prstGeom prst="rect">
-            <a:avLst/>
-          </a:prstGeom>
-          <a:noFill/>
-        </p:spPr>
-        <p:txBody>
-          <a:bodyPr wrap="square" lIns="22412" tIns="11206" rIns="22412" bIns="11206" anchor="ctr">
-            <a:spAutoFit/>
-          </a:bodyPr>
-          <a:lstStyle/>
-          <a:p>
-            <a:pPr algn="r"/>
-            <a:r>
-              <a:rPr sz="900">
-                <a:solidFill>
-                  <a:srgbClr val="111111"/>
-                </a:solidFill>
-                <a:latin typeface="Times New Roman" panose="02020603050405020304" pitchFamily="18" charset="0"/>
-                <a:cs typeface="Times New Roman" panose="02020603050405020304" pitchFamily="18" charset="0"/>
-              </a:rPr>
-              <a:t>2009</a:t>
-            </a:r>
-          </a:p>
-        </p:txBody>
-      </p:sp>
-      <p:cxnSp>
-        <p:nvCxnSpPr>
-          <p:cNvPr id="67" name="Connector 66"/>
-          <p:cNvCxnSpPr/>
-          <p:nvPr/>
-        </p:nvCxnSpPr>
-        <p:spPr>
-          <a:xfrm>
-            <a:off x="6191708" y="2978278"/>
-            <a:ext cx="64546" cy="0"/>
-          </a:xfrm>
-          <a:prstGeom prst="line">
-            <a:avLst/>
-          </a:prstGeom>
-          <a:ln w="10160">
-            <a:solidFill>
-              <a:srgbClr val="252525"/>
-            </a:solidFill>
-          </a:ln>
-        </p:spPr>
-        <p:style>
-          <a:lnRef idx="2">
-            <a:schemeClr val="accent1"/>
-          </a:lnRef>
-          <a:fillRef idx="0">
-            <a:schemeClr val="accent1"/>
-          </a:fillRef>
-          <a:effectRef idx="1">
-            <a:schemeClr val="accent1"/>
-          </a:effectRef>
-          <a:fontRef idx="minor">
-            <a:schemeClr val="tx1"/>
-          </a:fontRef>
-        </p:style>
-      </p:cxnSp>
-      <p:sp>
-        <p:nvSpPr>
-          <p:cNvPr id="68" name="TextBox 67"/>
-          <p:cNvSpPr txBox="1"/>
-          <p:nvPr/>
-        </p:nvSpPr>
-        <p:spPr>
-          <a:xfrm>
-            <a:off x="5868978" y="3136094"/>
-            <a:ext cx="338866" cy="161130"/>
-          </a:xfrm>
-          <a:prstGeom prst="rect">
-            <a:avLst/>
-          </a:prstGeom>
-          <a:noFill/>
-        </p:spPr>
-        <p:txBody>
-          <a:bodyPr wrap="square" lIns="22412" tIns="11206" rIns="22412" bIns="11206" anchor="ctr">
-            <a:spAutoFit/>
-          </a:bodyPr>
-          <a:lstStyle/>
-          <a:p>
-            <a:pPr algn="r"/>
-            <a:r>
-              <a:rPr sz="900">
-                <a:solidFill>
-                  <a:srgbClr val="111111"/>
-                </a:solidFill>
-                <a:latin typeface="Times New Roman" panose="02020603050405020304" pitchFamily="18" charset="0"/>
-                <a:cs typeface="Times New Roman" panose="02020603050405020304" pitchFamily="18" charset="0"/>
-              </a:rPr>
-              <a:t>2010</a:t>
-            </a:r>
-          </a:p>
-        </p:txBody>
-      </p:sp>
-      <p:cxnSp>
-        <p:nvCxnSpPr>
-          <p:cNvPr id="69" name="Connector 68"/>
-          <p:cNvCxnSpPr/>
-          <p:nvPr/>
-        </p:nvCxnSpPr>
-        <p:spPr>
-          <a:xfrm>
-            <a:off x="6191708" y="3216658"/>
-            <a:ext cx="64546" cy="0"/>
-          </a:xfrm>
-          <a:prstGeom prst="line">
-            <a:avLst/>
-          </a:prstGeom>
-          <a:ln w="10160">
-            <a:solidFill>
-              <a:srgbClr val="252525"/>
-            </a:solidFill>
-          </a:ln>
-        </p:spPr>
-        <p:style>
-          <a:lnRef idx="2">
-            <a:schemeClr val="accent1"/>
-          </a:lnRef>
-          <a:fillRef idx="0">
-            <a:schemeClr val="accent1"/>
-          </a:fillRef>
-          <a:effectRef idx="1">
-            <a:schemeClr val="accent1"/>
-          </a:effectRef>
-          <a:fontRef idx="minor">
-            <a:schemeClr val="tx1"/>
-          </a:fontRef>
-        </p:style>
-      </p:cxnSp>
-      <p:sp>
-        <p:nvSpPr>
-          <p:cNvPr id="70" name="TextBox 69"/>
-          <p:cNvSpPr txBox="1"/>
-          <p:nvPr/>
-        </p:nvSpPr>
-        <p:spPr>
-          <a:xfrm>
-            <a:off x="5868978" y="3374474"/>
-            <a:ext cx="338866" cy="161130"/>
-          </a:xfrm>
-          <a:prstGeom prst="rect">
-            <a:avLst/>
-          </a:prstGeom>
-          <a:noFill/>
-        </p:spPr>
-        <p:txBody>
-          <a:bodyPr wrap="square" lIns="22412" tIns="11206" rIns="22412" bIns="11206" anchor="ctr">
-            <a:spAutoFit/>
-          </a:bodyPr>
-          <a:lstStyle/>
-          <a:p>
-            <a:pPr algn="r"/>
-            <a:r>
-              <a:rPr sz="900">
-                <a:solidFill>
-                  <a:srgbClr val="111111"/>
-                </a:solidFill>
-                <a:latin typeface="Times New Roman" panose="02020603050405020304" pitchFamily="18" charset="0"/>
-                <a:cs typeface="Times New Roman" panose="02020603050405020304" pitchFamily="18" charset="0"/>
-              </a:rPr>
-              <a:t>2011</a:t>
-            </a:r>
-          </a:p>
-        </p:txBody>
-      </p:sp>
-      <p:cxnSp>
-        <p:nvCxnSpPr>
-          <p:cNvPr id="71" name="Connector 70"/>
-          <p:cNvCxnSpPr/>
-          <p:nvPr/>
-        </p:nvCxnSpPr>
-        <p:spPr>
-          <a:xfrm>
-            <a:off x="6191708" y="3455038"/>
-            <a:ext cx="64546" cy="0"/>
-          </a:xfrm>
-          <a:prstGeom prst="line">
-            <a:avLst/>
-          </a:prstGeom>
-          <a:ln w="10160">
-            <a:solidFill>
-              <a:srgbClr val="252525"/>
-            </a:solidFill>
-          </a:ln>
-        </p:spPr>
-        <p:style>
-          <a:lnRef idx="2">
-            <a:schemeClr val="accent1"/>
-          </a:lnRef>
-          <a:fillRef idx="0">
-            <a:schemeClr val="accent1"/>
-          </a:fillRef>
-          <a:effectRef idx="1">
-            <a:schemeClr val="accent1"/>
-          </a:effectRef>
-          <a:fontRef idx="minor">
-            <a:schemeClr val="tx1"/>
-          </a:fontRef>
-        </p:style>
-      </p:cxnSp>
-      <p:sp>
-        <p:nvSpPr>
-          <p:cNvPr id="72" name="TextBox 71"/>
-          <p:cNvSpPr txBox="1"/>
-          <p:nvPr/>
-        </p:nvSpPr>
-        <p:spPr>
-          <a:xfrm>
-            <a:off x="5868978" y="3612853"/>
-            <a:ext cx="338866" cy="161130"/>
-          </a:xfrm>
-          <a:prstGeom prst="rect">
-            <a:avLst/>
-          </a:prstGeom>
-          <a:noFill/>
-        </p:spPr>
-        <p:txBody>
-          <a:bodyPr wrap="square" lIns="22412" tIns="11206" rIns="22412" bIns="11206" anchor="ctr">
-            <a:spAutoFit/>
-          </a:bodyPr>
-          <a:lstStyle/>
-          <a:p>
-            <a:pPr algn="r"/>
-            <a:r>
-              <a:rPr sz="900">
-                <a:solidFill>
-                  <a:srgbClr val="111111"/>
-                </a:solidFill>
-                <a:latin typeface="Times New Roman" panose="02020603050405020304" pitchFamily="18" charset="0"/>
-                <a:cs typeface="Times New Roman" panose="02020603050405020304" pitchFamily="18" charset="0"/>
-              </a:rPr>
-              <a:t>2012</a:t>
-            </a:r>
-          </a:p>
-        </p:txBody>
-      </p:sp>
-      <p:cxnSp>
-        <p:nvCxnSpPr>
-          <p:cNvPr id="73" name="Connector 72"/>
-          <p:cNvCxnSpPr/>
-          <p:nvPr/>
-        </p:nvCxnSpPr>
-        <p:spPr>
-          <a:xfrm>
-            <a:off x="6191708" y="3693417"/>
-            <a:ext cx="64546" cy="0"/>
-          </a:xfrm>
-          <a:prstGeom prst="line">
-            <a:avLst/>
-          </a:prstGeom>
-          <a:ln w="10160">
-            <a:solidFill>
-              <a:srgbClr val="252525"/>
-            </a:solidFill>
-          </a:ln>
-        </p:spPr>
-        <p:style>
-          <a:lnRef idx="2">
-            <a:schemeClr val="accent1"/>
-          </a:lnRef>
-          <a:fillRef idx="0">
-            <a:schemeClr val="accent1"/>
-          </a:fillRef>
-          <a:effectRef idx="1">
-            <a:schemeClr val="accent1"/>
-          </a:effectRef>
-          <a:fontRef idx="minor">
-            <a:schemeClr val="tx1"/>
-          </a:fontRef>
-        </p:style>
-      </p:cxnSp>
-      <p:sp>
-        <p:nvSpPr>
-          <p:cNvPr id="74" name="TextBox 73"/>
-          <p:cNvSpPr txBox="1"/>
-          <p:nvPr/>
-        </p:nvSpPr>
-        <p:spPr>
-          <a:xfrm>
-            <a:off x="5868978" y="3851233"/>
-            <a:ext cx="338866" cy="161130"/>
-          </a:xfrm>
-          <a:prstGeom prst="rect">
-            <a:avLst/>
-          </a:prstGeom>
-          <a:noFill/>
-        </p:spPr>
-        <p:txBody>
-          <a:bodyPr wrap="square" lIns="22412" tIns="11206" rIns="22412" bIns="11206" anchor="ctr">
-            <a:spAutoFit/>
-          </a:bodyPr>
-          <a:lstStyle/>
-          <a:p>
-            <a:pPr algn="r"/>
-            <a:r>
-              <a:rPr sz="900">
-                <a:solidFill>
-                  <a:srgbClr val="111111"/>
-                </a:solidFill>
-                <a:latin typeface="Times New Roman" panose="02020603050405020304" pitchFamily="18" charset="0"/>
-                <a:cs typeface="Times New Roman" panose="02020603050405020304" pitchFamily="18" charset="0"/>
-              </a:rPr>
-              <a:t>2013</a:t>
-            </a:r>
-          </a:p>
-        </p:txBody>
-      </p:sp>
-      <p:cxnSp>
-        <p:nvCxnSpPr>
-          <p:cNvPr id="75" name="Connector 74"/>
-          <p:cNvCxnSpPr/>
-          <p:nvPr/>
-        </p:nvCxnSpPr>
-        <p:spPr>
-          <a:xfrm>
-            <a:off x="6191708" y="3931797"/>
-            <a:ext cx="64546" cy="0"/>
-          </a:xfrm>
-          <a:prstGeom prst="line">
-            <a:avLst/>
-          </a:prstGeom>
-          <a:ln w="10160">
-            <a:solidFill>
-              <a:srgbClr val="252525"/>
-            </a:solidFill>
-          </a:ln>
-        </p:spPr>
-        <p:style>
-          <a:lnRef idx="2">
-            <a:schemeClr val="accent1"/>
-          </a:lnRef>
-          <a:fillRef idx="0">
-            <a:schemeClr val="accent1"/>
-          </a:fillRef>
-          <a:effectRef idx="1">
-            <a:schemeClr val="accent1"/>
-          </a:effectRef>
-          <a:fontRef idx="minor">
-            <a:schemeClr val="tx1"/>
-          </a:fontRef>
-        </p:style>
-      </p:cxnSp>
-      <p:sp>
-        <p:nvSpPr>
-          <p:cNvPr id="76" name="TextBox 75"/>
-          <p:cNvSpPr txBox="1"/>
-          <p:nvPr/>
-        </p:nvSpPr>
-        <p:spPr>
-          <a:xfrm>
-            <a:off x="5868978" y="4089613"/>
-            <a:ext cx="338866" cy="161130"/>
-          </a:xfrm>
-          <a:prstGeom prst="rect">
-            <a:avLst/>
-          </a:prstGeom>
-          <a:noFill/>
-        </p:spPr>
-        <p:txBody>
-          <a:bodyPr wrap="square" lIns="22412" tIns="11206" rIns="22412" bIns="11206" anchor="ctr">
-            <a:spAutoFit/>
-          </a:bodyPr>
-          <a:lstStyle/>
-          <a:p>
-            <a:pPr algn="r"/>
-            <a:r>
-              <a:rPr sz="900">
-                <a:solidFill>
-                  <a:srgbClr val="111111"/>
-                </a:solidFill>
-                <a:latin typeface="Times New Roman" panose="02020603050405020304" pitchFamily="18" charset="0"/>
-                <a:cs typeface="Times New Roman" panose="02020603050405020304" pitchFamily="18" charset="0"/>
-              </a:rPr>
-              <a:t>2014</a:t>
-            </a:r>
-          </a:p>
-        </p:txBody>
-      </p:sp>
-      <p:cxnSp>
-        <p:nvCxnSpPr>
-          <p:cNvPr id="77" name="Connector 76"/>
-          <p:cNvCxnSpPr/>
-          <p:nvPr/>
-        </p:nvCxnSpPr>
-        <p:spPr>
-          <a:xfrm>
-            <a:off x="6191708" y="4170177"/>
-            <a:ext cx="64546" cy="0"/>
-          </a:xfrm>
-          <a:prstGeom prst="line">
-            <a:avLst/>
-          </a:prstGeom>
-          <a:ln w="10160">
-            <a:solidFill>
-              <a:srgbClr val="252525"/>
-            </a:solidFill>
-          </a:ln>
-        </p:spPr>
-        <p:style>
-          <a:lnRef idx="2">
-            <a:schemeClr val="accent1"/>
-          </a:lnRef>
-          <a:fillRef idx="0">
-            <a:schemeClr val="accent1"/>
-          </a:fillRef>
-          <a:effectRef idx="1">
-            <a:schemeClr val="accent1"/>
-          </a:effectRef>
-          <a:fontRef idx="minor">
-            <a:schemeClr val="tx1"/>
-          </a:fontRef>
-        </p:style>
-      </p:cxnSp>
-      <p:sp>
-        <p:nvSpPr>
-          <p:cNvPr id="78" name="TextBox 77"/>
-          <p:cNvSpPr txBox="1"/>
-          <p:nvPr/>
-        </p:nvSpPr>
-        <p:spPr>
-          <a:xfrm>
-            <a:off x="5868978" y="4327992"/>
-            <a:ext cx="338866" cy="161130"/>
-          </a:xfrm>
-          <a:prstGeom prst="rect">
-            <a:avLst/>
-          </a:prstGeom>
-          <a:noFill/>
-        </p:spPr>
-        <p:txBody>
-          <a:bodyPr wrap="square" lIns="22412" tIns="11206" rIns="22412" bIns="11206" anchor="ctr">
-            <a:spAutoFit/>
-          </a:bodyPr>
-          <a:lstStyle/>
-          <a:p>
-            <a:pPr algn="r"/>
-            <a:r>
-              <a:rPr sz="900">
-                <a:solidFill>
-                  <a:srgbClr val="111111"/>
-                </a:solidFill>
-                <a:latin typeface="Times New Roman" panose="02020603050405020304" pitchFamily="18" charset="0"/>
-                <a:cs typeface="Times New Roman" panose="02020603050405020304" pitchFamily="18" charset="0"/>
-              </a:rPr>
-              <a:t>2015</a:t>
-            </a:r>
-          </a:p>
-        </p:txBody>
-      </p:sp>
-      <p:cxnSp>
-        <p:nvCxnSpPr>
-          <p:cNvPr id="79" name="Connector 78"/>
-          <p:cNvCxnSpPr/>
-          <p:nvPr/>
-        </p:nvCxnSpPr>
-        <p:spPr>
-          <a:xfrm>
-            <a:off x="6191708" y="4408556"/>
-            <a:ext cx="64546" cy="0"/>
-          </a:xfrm>
-          <a:prstGeom prst="line">
-            <a:avLst/>
-          </a:prstGeom>
-          <a:ln w="10160">
-            <a:solidFill>
-              <a:srgbClr val="252525"/>
-            </a:solidFill>
-          </a:ln>
-        </p:spPr>
-        <p:style>
-          <a:lnRef idx="2">
-            <a:schemeClr val="accent1"/>
-          </a:lnRef>
-          <a:fillRef idx="0">
-            <a:schemeClr val="accent1"/>
-          </a:fillRef>
-          <a:effectRef idx="1">
-            <a:schemeClr val="accent1"/>
-          </a:effectRef>
-          <a:fontRef idx="minor">
-            <a:schemeClr val="tx1"/>
-          </a:fontRef>
-        </p:style>
-      </p:cxnSp>
-      <p:sp>
-        <p:nvSpPr>
-          <p:cNvPr id="80" name="TextBox 79"/>
-          <p:cNvSpPr txBox="1"/>
-          <p:nvPr/>
-        </p:nvSpPr>
-        <p:spPr>
-          <a:xfrm>
-            <a:off x="5868978" y="4566372"/>
-            <a:ext cx="338866" cy="161130"/>
-          </a:xfrm>
-          <a:prstGeom prst="rect">
-            <a:avLst/>
-          </a:prstGeom>
-          <a:noFill/>
-        </p:spPr>
-        <p:txBody>
-          <a:bodyPr wrap="square" lIns="22412" tIns="11206" rIns="22412" bIns="11206" anchor="ctr">
-            <a:spAutoFit/>
-          </a:bodyPr>
-          <a:lstStyle/>
-          <a:p>
-            <a:pPr algn="r"/>
-            <a:r>
-              <a:rPr sz="900">
-                <a:solidFill>
-                  <a:srgbClr val="111111"/>
-                </a:solidFill>
-                <a:latin typeface="Times New Roman" panose="02020603050405020304" pitchFamily="18" charset="0"/>
-                <a:cs typeface="Times New Roman" panose="02020603050405020304" pitchFamily="18" charset="0"/>
-              </a:rPr>
-              <a:t>2016</a:t>
-            </a:r>
-          </a:p>
-        </p:txBody>
-      </p:sp>
-      <p:cxnSp>
-        <p:nvCxnSpPr>
-          <p:cNvPr id="81" name="Connector 80"/>
-          <p:cNvCxnSpPr/>
-          <p:nvPr/>
-        </p:nvCxnSpPr>
-        <p:spPr>
-          <a:xfrm>
-            <a:off x="6191708" y="4646936"/>
-            <a:ext cx="64546" cy="0"/>
-          </a:xfrm>
-          <a:prstGeom prst="line">
-            <a:avLst/>
-          </a:prstGeom>
-          <a:ln w="10160">
-            <a:solidFill>
-              <a:srgbClr val="252525"/>
-            </a:solidFill>
-          </a:ln>
-        </p:spPr>
-        <p:style>
-          <a:lnRef idx="2">
-            <a:schemeClr val="accent1"/>
-          </a:lnRef>
-          <a:fillRef idx="0">
-            <a:schemeClr val="accent1"/>
-          </a:fillRef>
-          <a:effectRef idx="1">
-            <a:schemeClr val="accent1"/>
-          </a:effectRef>
-          <a:fontRef idx="minor">
-            <a:schemeClr val="tx1"/>
-          </a:fontRef>
-        </p:style>
-      </p:cxnSp>
-      <p:sp>
-        <p:nvSpPr>
-          <p:cNvPr id="82" name="TextBox 81"/>
-          <p:cNvSpPr txBox="1"/>
-          <p:nvPr/>
-        </p:nvSpPr>
-        <p:spPr>
-          <a:xfrm>
-            <a:off x="5868978" y="4804752"/>
-            <a:ext cx="338866" cy="161130"/>
-          </a:xfrm>
-          <a:prstGeom prst="rect">
-            <a:avLst/>
-          </a:prstGeom>
-          <a:noFill/>
-        </p:spPr>
-        <p:txBody>
-          <a:bodyPr wrap="square" lIns="22412" tIns="11206" rIns="22412" bIns="11206" anchor="ctr">
-            <a:spAutoFit/>
-          </a:bodyPr>
-          <a:lstStyle/>
-          <a:p>
-            <a:pPr algn="r"/>
-            <a:r>
-              <a:rPr sz="900">
-                <a:solidFill>
-                  <a:srgbClr val="111111"/>
-                </a:solidFill>
-                <a:latin typeface="Times New Roman" panose="02020603050405020304" pitchFamily="18" charset="0"/>
-                <a:cs typeface="Times New Roman" panose="02020603050405020304" pitchFamily="18" charset="0"/>
-              </a:rPr>
-              <a:t>2017</a:t>
-            </a:r>
-          </a:p>
-        </p:txBody>
-      </p:sp>
-      <p:cxnSp>
-        <p:nvCxnSpPr>
-          <p:cNvPr id="83" name="Connector 82"/>
-          <p:cNvCxnSpPr/>
-          <p:nvPr/>
-        </p:nvCxnSpPr>
-        <p:spPr>
-          <a:xfrm>
-            <a:off x="6191708" y="4885316"/>
-            <a:ext cx="64546" cy="0"/>
-          </a:xfrm>
-          <a:prstGeom prst="line">
-            <a:avLst/>
-          </a:prstGeom>
-          <a:ln w="10160">
-            <a:solidFill>
-              <a:srgbClr val="252525"/>
-            </a:solidFill>
-          </a:ln>
-        </p:spPr>
-        <p:style>
-          <a:lnRef idx="2">
-            <a:schemeClr val="accent1"/>
-          </a:lnRef>
-          <a:fillRef idx="0">
-            <a:schemeClr val="accent1"/>
-          </a:fillRef>
-          <a:effectRef idx="1">
-            <a:schemeClr val="accent1"/>
-          </a:effectRef>
-          <a:fontRef idx="minor">
-            <a:schemeClr val="tx1"/>
-          </a:fontRef>
-        </p:style>
-      </p:cxnSp>
-      <p:sp>
-        <p:nvSpPr>
-          <p:cNvPr id="84" name="TextBox 83"/>
-          <p:cNvSpPr txBox="1"/>
-          <p:nvPr/>
-        </p:nvSpPr>
-        <p:spPr>
-          <a:xfrm>
-            <a:off x="5868978" y="5043132"/>
-            <a:ext cx="338866" cy="161130"/>
-          </a:xfrm>
-          <a:prstGeom prst="rect">
-            <a:avLst/>
-          </a:prstGeom>
-          <a:noFill/>
-        </p:spPr>
-        <p:txBody>
-          <a:bodyPr wrap="square" lIns="22412" tIns="11206" rIns="22412" bIns="11206" anchor="ctr">
-            <a:spAutoFit/>
-          </a:bodyPr>
-          <a:lstStyle/>
-          <a:p>
-            <a:pPr algn="r"/>
-            <a:r>
-              <a:rPr sz="900">
-                <a:solidFill>
-                  <a:srgbClr val="111111"/>
-                </a:solidFill>
-                <a:latin typeface="Times New Roman" panose="02020603050405020304" pitchFamily="18" charset="0"/>
-                <a:cs typeface="Times New Roman" panose="02020603050405020304" pitchFamily="18" charset="0"/>
-              </a:rPr>
-              <a:t>2018</a:t>
-            </a:r>
-          </a:p>
-        </p:txBody>
-      </p:sp>
-      <p:cxnSp>
-        <p:nvCxnSpPr>
-          <p:cNvPr id="85" name="Connector 84"/>
-          <p:cNvCxnSpPr/>
-          <p:nvPr/>
-        </p:nvCxnSpPr>
-        <p:spPr>
-          <a:xfrm>
-            <a:off x="6191708" y="5123696"/>
-            <a:ext cx="64546" cy="0"/>
-          </a:xfrm>
-          <a:prstGeom prst="line">
-            <a:avLst/>
-          </a:prstGeom>
-          <a:ln w="10160">
-            <a:solidFill>
-              <a:srgbClr val="252525"/>
-            </a:solidFill>
-          </a:ln>
-        </p:spPr>
-        <p:style>
-          <a:lnRef idx="2">
-            <a:schemeClr val="accent1"/>
-          </a:lnRef>
-          <a:fillRef idx="0">
-            <a:schemeClr val="accent1"/>
-          </a:fillRef>
-          <a:effectRef idx="1">
-            <a:schemeClr val="accent1"/>
-          </a:effectRef>
-          <a:fontRef idx="minor">
-            <a:schemeClr val="tx1"/>
-          </a:fontRef>
-        </p:style>
-      </p:cxnSp>
-      <p:sp>
-        <p:nvSpPr>
-          <p:cNvPr id="86" name="TextBox 85"/>
-          <p:cNvSpPr txBox="1"/>
-          <p:nvPr/>
-        </p:nvSpPr>
-        <p:spPr>
-          <a:xfrm>
-            <a:off x="5868978" y="5281512"/>
-            <a:ext cx="338866" cy="161130"/>
-          </a:xfrm>
-          <a:prstGeom prst="rect">
-            <a:avLst/>
-          </a:prstGeom>
-          <a:noFill/>
-        </p:spPr>
-        <p:txBody>
-          <a:bodyPr wrap="square" lIns="22412" tIns="11206" rIns="22412" bIns="11206" anchor="ctr">
-            <a:spAutoFit/>
-          </a:bodyPr>
-          <a:lstStyle/>
-          <a:p>
-            <a:pPr algn="r"/>
-            <a:r>
-              <a:rPr sz="900">
-                <a:solidFill>
-                  <a:srgbClr val="111111"/>
-                </a:solidFill>
-                <a:latin typeface="Times New Roman" panose="02020603050405020304" pitchFamily="18" charset="0"/>
-                <a:cs typeface="Times New Roman" panose="02020603050405020304" pitchFamily="18" charset="0"/>
-              </a:rPr>
-              <a:t>2019</a:t>
-            </a:r>
-          </a:p>
-        </p:txBody>
-      </p:sp>
-      <p:cxnSp>
-        <p:nvCxnSpPr>
-          <p:cNvPr id="87" name="Connector 86"/>
-          <p:cNvCxnSpPr/>
-          <p:nvPr/>
-        </p:nvCxnSpPr>
-        <p:spPr>
-          <a:xfrm>
-            <a:off x="6191708" y="5362076"/>
-            <a:ext cx="64546" cy="0"/>
-          </a:xfrm>
-          <a:prstGeom prst="line">
-            <a:avLst/>
-          </a:prstGeom>
-          <a:ln w="10160">
-            <a:solidFill>
-              <a:srgbClr val="252525"/>
-            </a:solidFill>
-          </a:ln>
-        </p:spPr>
-        <p:style>
-          <a:lnRef idx="2">
-            <a:schemeClr val="accent1"/>
-          </a:lnRef>
-          <a:fillRef idx="0">
-            <a:schemeClr val="accent1"/>
-          </a:fillRef>
-          <a:effectRef idx="1">
-            <a:schemeClr val="accent1"/>
-          </a:effectRef>
-          <a:fontRef idx="minor">
-            <a:schemeClr val="tx1"/>
-          </a:fontRef>
-        </p:style>
-      </p:cxnSp>
-      <p:sp>
-        <p:nvSpPr>
-          <p:cNvPr id="88" name="TextBox 87"/>
-          <p:cNvSpPr txBox="1"/>
-          <p:nvPr/>
-        </p:nvSpPr>
-        <p:spPr>
-          <a:xfrm>
-            <a:off x="5868978" y="5519891"/>
-            <a:ext cx="338866" cy="161130"/>
-          </a:xfrm>
-          <a:prstGeom prst="rect">
-            <a:avLst/>
-          </a:prstGeom>
-          <a:noFill/>
-        </p:spPr>
-        <p:txBody>
-          <a:bodyPr wrap="square" lIns="22412" tIns="11206" rIns="22412" bIns="11206" anchor="ctr">
-            <a:spAutoFit/>
-          </a:bodyPr>
-          <a:lstStyle/>
-          <a:p>
-            <a:pPr algn="r"/>
-            <a:r>
-              <a:rPr sz="900">
-                <a:solidFill>
-                  <a:srgbClr val="111111"/>
-                </a:solidFill>
-                <a:latin typeface="Times New Roman" panose="02020603050405020304" pitchFamily="18" charset="0"/>
-                <a:cs typeface="Times New Roman" panose="02020603050405020304" pitchFamily="18" charset="0"/>
-              </a:rPr>
-              <a:t>2020</a:t>
-            </a:r>
-          </a:p>
-        </p:txBody>
-      </p:sp>
-      <p:cxnSp>
-        <p:nvCxnSpPr>
-          <p:cNvPr id="89" name="Connector 88"/>
-          <p:cNvCxnSpPr/>
-          <p:nvPr/>
-        </p:nvCxnSpPr>
-        <p:spPr>
-          <a:xfrm>
-            <a:off x="6191708" y="5600455"/>
-            <a:ext cx="64546" cy="0"/>
-          </a:xfrm>
-          <a:prstGeom prst="line">
-            <a:avLst/>
-          </a:prstGeom>
-          <a:ln w="10160">
-            <a:solidFill>
-              <a:srgbClr val="252525"/>
-            </a:solidFill>
-          </a:ln>
-        </p:spPr>
-        <p:style>
-          <a:lnRef idx="2">
-            <a:schemeClr val="accent1"/>
-          </a:lnRef>
-          <a:fillRef idx="0">
-            <a:schemeClr val="accent1"/>
-          </a:fillRef>
-          <a:effectRef idx="1">
-            <a:schemeClr val="accent1"/>
-          </a:effectRef>
-          <a:fontRef idx="minor">
-            <a:schemeClr val="tx1"/>
-          </a:fontRef>
-        </p:style>
-      </p:cxnSp>
-      <p:sp>
-        <p:nvSpPr>
-          <p:cNvPr id="90" name="TextBox 89"/>
-          <p:cNvSpPr txBox="1"/>
-          <p:nvPr/>
-        </p:nvSpPr>
-        <p:spPr>
-          <a:xfrm>
-            <a:off x="5868978" y="5758271"/>
-            <a:ext cx="338866" cy="161130"/>
-          </a:xfrm>
-          <a:prstGeom prst="rect">
-            <a:avLst/>
-          </a:prstGeom>
-          <a:noFill/>
-        </p:spPr>
-        <p:txBody>
-          <a:bodyPr wrap="square" lIns="22412" tIns="11206" rIns="22412" bIns="11206" anchor="ctr">
-            <a:spAutoFit/>
-          </a:bodyPr>
-          <a:lstStyle/>
-          <a:p>
-            <a:pPr algn="r"/>
-            <a:r>
-              <a:rPr sz="900">
-                <a:solidFill>
-                  <a:srgbClr val="111111"/>
-                </a:solidFill>
-                <a:latin typeface="Times New Roman" panose="02020603050405020304" pitchFamily="18" charset="0"/>
-                <a:cs typeface="Times New Roman" panose="02020603050405020304" pitchFamily="18" charset="0"/>
-              </a:rPr>
-              <a:t>2021</a:t>
-            </a:r>
-          </a:p>
-        </p:txBody>
-      </p:sp>
-      <p:cxnSp>
-        <p:nvCxnSpPr>
-          <p:cNvPr id="91" name="Connector 90"/>
-          <p:cNvCxnSpPr/>
-          <p:nvPr/>
-        </p:nvCxnSpPr>
-        <p:spPr>
-          <a:xfrm>
-            <a:off x="6191708" y="5838835"/>
-            <a:ext cx="64546" cy="0"/>
-          </a:xfrm>
-          <a:prstGeom prst="line">
-            <a:avLst/>
-          </a:prstGeom>
-          <a:ln w="10160">
-            <a:solidFill>
-              <a:srgbClr val="252525"/>
-            </a:solidFill>
-          </a:ln>
-        </p:spPr>
-        <p:style>
-          <a:lnRef idx="2">
-            <a:schemeClr val="accent1"/>
-          </a:lnRef>
-          <a:fillRef idx="0">
-            <a:schemeClr val="accent1"/>
-          </a:fillRef>
-          <a:effectRef idx="1">
-            <a:schemeClr val="accent1"/>
-          </a:effectRef>
-          <a:fontRef idx="minor">
-            <a:schemeClr val="tx1"/>
-          </a:fontRef>
-        </p:style>
-      </p:cxnSp>
-      <p:sp>
-        <p:nvSpPr>
-          <p:cNvPr id="92" name="TextBox 91"/>
-          <p:cNvSpPr txBox="1"/>
-          <p:nvPr/>
-        </p:nvSpPr>
-        <p:spPr>
-          <a:xfrm>
-            <a:off x="5868978" y="5996651"/>
-            <a:ext cx="338866" cy="161130"/>
-          </a:xfrm>
-          <a:prstGeom prst="rect">
-            <a:avLst/>
-          </a:prstGeom>
-          <a:noFill/>
-        </p:spPr>
-        <p:txBody>
-          <a:bodyPr wrap="square" lIns="22412" tIns="11206" rIns="22412" bIns="11206" anchor="ctr">
-            <a:spAutoFit/>
-          </a:bodyPr>
-          <a:lstStyle/>
-          <a:p>
-            <a:pPr algn="r"/>
-            <a:r>
-              <a:rPr sz="900">
-                <a:solidFill>
-                  <a:srgbClr val="111111"/>
-                </a:solidFill>
-                <a:latin typeface="Times New Roman" panose="02020603050405020304" pitchFamily="18" charset="0"/>
-                <a:cs typeface="Times New Roman" panose="02020603050405020304" pitchFamily="18" charset="0"/>
-              </a:rPr>
-              <a:t>2022</a:t>
-            </a:r>
-          </a:p>
-        </p:txBody>
-      </p:sp>
-      <p:cxnSp>
-        <p:nvCxnSpPr>
-          <p:cNvPr id="93" name="Connector 92"/>
-          <p:cNvCxnSpPr/>
-          <p:nvPr/>
-        </p:nvCxnSpPr>
-        <p:spPr>
-          <a:xfrm>
-            <a:off x="6191708" y="6077215"/>
             <a:ext cx="64546" cy="0"/>
           </a:xfrm>
           <a:prstGeom prst="line">
@@ -8841,7 +7279,7 @@
         </p:nvSpPr>
         <p:spPr>
           <a:xfrm>
-            <a:off x="6256254" y="952052"/>
+            <a:off x="5857662" y="952052"/>
             <a:ext cx="1307054" cy="715138"/>
           </a:xfrm>
           <a:prstGeom prst="rect">
@@ -8890,7 +7328,7 @@
         </p:nvSpPr>
         <p:spPr>
           <a:xfrm>
-            <a:off x="6256254" y="1667190"/>
+            <a:off x="5857662" y="1667190"/>
             <a:ext cx="1307054" cy="715138"/>
           </a:xfrm>
           <a:prstGeom prst="rect">
@@ -8939,7 +7377,7 @@
         </p:nvSpPr>
         <p:spPr>
           <a:xfrm>
-            <a:off x="6256254" y="2382329"/>
+            <a:off x="5857662" y="2382329"/>
             <a:ext cx="1307054" cy="943802"/>
           </a:xfrm>
           <a:prstGeom prst="rect">
@@ -8988,7 +7426,7 @@
         </p:nvSpPr>
         <p:spPr>
           <a:xfrm>
-            <a:off x="6256254" y="3320428"/>
+            <a:off x="5857662" y="3320428"/>
             <a:ext cx="1307054" cy="502908"/>
           </a:xfrm>
           <a:prstGeom prst="rect">
@@ -9037,7 +7475,7 @@
         </p:nvSpPr>
         <p:spPr>
           <a:xfrm>
-            <a:off x="6256254" y="3817620"/>
+            <a:off x="5857662" y="3817620"/>
             <a:ext cx="1307054" cy="710127"/>
           </a:xfrm>
           <a:prstGeom prst="rect">
@@ -9086,7 +7524,7 @@
         </p:nvSpPr>
         <p:spPr>
           <a:xfrm>
-            <a:off x="6256254" y="4527747"/>
+            <a:off x="5857662" y="4527747"/>
             <a:ext cx="1307054" cy="1668657"/>
           </a:xfrm>
           <a:prstGeom prst="rect">
@@ -9135,7 +7573,7 @@
         </p:nvSpPr>
         <p:spPr>
           <a:xfrm>
-            <a:off x="6256254" y="952052"/>
+            <a:off x="5857662" y="952052"/>
             <a:ext cx="1307054" cy="5244353"/>
           </a:xfrm>
           <a:prstGeom prst="rect">
@@ -9205,7 +7643,7 @@
                 <a:latin typeface="Times New Roman" panose="02020603050405020304" pitchFamily="18" charset="0"/>
                 <a:cs typeface="Times New Roman" panose="02020603050405020304" pitchFamily="18" charset="0"/>
               </a:rPr>
-              <a:t>2004: Operational withdrawal from the Depression</a:t>
+              <a:t>2004: Withdrawal of park authorities</a:t>
             </a:r>
           </a:p>
         </p:txBody>
@@ -9219,7 +7657,7 @@
         <p:spPr>
           <a:xfrm>
             <a:off x="2600130" y="1558286"/>
-            <a:ext cx="1532965" cy="638184"/>
+            <a:ext cx="1532965" cy="515073"/>
           </a:xfrm>
           <a:prstGeom prst="rect">
             <a:avLst/>
@@ -9241,7 +7679,7 @@
                 <a:latin typeface="Times New Roman" panose="02020603050405020304" pitchFamily="18" charset="0"/>
                 <a:cs typeface="Times New Roman" panose="02020603050405020304" pitchFamily="18" charset="0"/>
               </a:rPr>
-              <a:t>The 28 May 2004 attack on Lusinga precipitated withdrawal from the Kamalondo Depression and the collapse of routine park enforcement.</a:t>
+              <a:t>The 28 May 2004 attack on Lusinga caused the withdrawal from the Depression and the collapse of routine park enforcement.</a:t>
             </a:r>
             <a:endParaRPr sz="800" dirty="0">
               <a:solidFill>
@@ -9294,7 +7732,7 @@
                 <a:latin typeface="Times New Roman" panose="02020603050405020304" pitchFamily="18" charset="0"/>
                 <a:cs typeface="Times New Roman" panose="02020603050405020304" pitchFamily="18" charset="0"/>
               </a:rPr>
-              <a:t>Post-demobilization fragmented re-entry</a:t>
+              <a:t>Post-demobilization park authority re-entry</a:t>
             </a:r>
             <a:endParaRPr sz="900" b="1" dirty="0">
               <a:solidFill>
@@ -9337,7 +7775,7 @@
                 <a:latin typeface="Times New Roman" panose="02020603050405020304" pitchFamily="18" charset="0"/>
                 <a:cs typeface="Times New Roman" panose="02020603050405020304" pitchFamily="18" charset="0"/>
               </a:rPr>
-              <a:t>Gédéon’s 2006 surrender was followed by partial conservation re-entry, negotiated access, and continuing residual armed presence.</a:t>
+              <a:t>Warlord Gédéon’s 2006 surrender was followed by partial resumption of conservation law enforcement activities.</a:t>
             </a:r>
             <a:endParaRPr sz="800" dirty="0">
               <a:solidFill>
@@ -9401,7 +7839,7 @@
         <p:spPr>
           <a:xfrm>
             <a:off x="2600130" y="3955746"/>
-            <a:ext cx="1532965" cy="638184"/>
+            <a:ext cx="1532965" cy="515073"/>
           </a:xfrm>
           <a:prstGeom prst="rect">
             <a:avLst/>
@@ -9423,7 +7861,7 @@
                 <a:latin typeface="Times New Roman" panose="02020603050405020304" pitchFamily="18" charset="0"/>
                 <a:cs typeface="Times New Roman" panose="02020603050405020304" pitchFamily="18" charset="0"/>
               </a:rPr>
-              <a:t>Renewed militia activity constrained park access; systematic operational penetration of the Depression was not documented until late 2016–2017.</a:t>
+              <a:t>Renewed militia activity constrained park access; systematic patrols of the Depression was not documented until late 2016–2017.</a:t>
             </a:r>
             <a:endParaRPr sz="800" dirty="0">
               <a:solidFill>
@@ -9509,7 +7947,7 @@
                 <a:latin typeface="Times New Roman" panose="02020603050405020304" pitchFamily="18" charset="0"/>
                 <a:cs typeface="Times New Roman" panose="02020603050405020304" pitchFamily="18" charset="0"/>
               </a:rPr>
-              <a:t>Elephant-protection operations and the new management arrangement extended systematic patrol reach beyond the Plateau core into the Depression.</a:t>
+              <a:t>Elephant-protection operations and the new management arrangement extended systematic patrol reach beyond the Plateau into the Depression.</a:t>
             </a:r>
             <a:endParaRPr sz="800" dirty="0">
               <a:solidFill>
@@ -9529,7 +7967,7 @@
         </p:nvSpPr>
         <p:spPr>
           <a:xfrm>
-            <a:off x="7714513" y="980261"/>
+            <a:off x="7315921" y="980261"/>
             <a:ext cx="1605579" cy="299630"/>
           </a:xfrm>
           <a:prstGeom prst="rect">
@@ -9572,8 +8010,8 @@
         </p:nvSpPr>
         <p:spPr>
           <a:xfrm>
-            <a:off x="7714513" y="1260160"/>
-            <a:ext cx="1605579" cy="638184"/>
+            <a:off x="7315921" y="1260160"/>
+            <a:ext cx="1605579" cy="515073"/>
           </a:xfrm>
           <a:prstGeom prst="rect">
             <a:avLst/>
@@ -9595,7 +8033,7 @@
                 <a:latin typeface="Times New Roman" panose="02020603050405020304" pitchFamily="18" charset="0"/>
                 <a:cs typeface="Times New Roman" panose="02020603050405020304" pitchFamily="18" charset="0"/>
               </a:rPr>
-              <a:t>The attack on Lusinga destroyed infrastructure, displaced staff and families, and precipitated the collapse of routine enforcement around the park headquarters.</a:t>
+              <a:t>The attack on Lusinga destroyed infrastructure, displaced staff and families, and caused the collapse of enforcement on the Plateau.</a:t>
             </a:r>
             <a:endParaRPr sz="800" dirty="0">
               <a:solidFill>
@@ -9615,8 +8053,8 @@
         </p:nvSpPr>
         <p:spPr>
           <a:xfrm>
-            <a:off x="7714514" y="2077003"/>
-            <a:ext cx="1403608" cy="299630"/>
+            <a:off x="7315922" y="2077003"/>
+            <a:ext cx="1403608" cy="161130"/>
           </a:xfrm>
           <a:prstGeom prst="rect">
             <a:avLst/>
@@ -9638,7 +8076,7 @@
                 <a:latin typeface="Times New Roman" panose="02020603050405020304" pitchFamily="18" charset="0"/>
                 <a:cs typeface="Times New Roman" panose="02020603050405020304" pitchFamily="18" charset="0"/>
               </a:rPr>
-              <a:t>2007: Fragmented conservation re-entry</a:t>
+              <a:t>2007: Patrol resumption</a:t>
             </a:r>
             <a:endParaRPr sz="900" b="1" dirty="0">
               <a:solidFill>
@@ -9658,7 +8096,7 @@
         </p:nvSpPr>
         <p:spPr>
           <a:xfrm>
-            <a:off x="7714513" y="2356901"/>
+            <a:off x="7315921" y="2215655"/>
             <a:ext cx="1605579" cy="515073"/>
           </a:xfrm>
           <a:prstGeom prst="rect">
@@ -9701,7 +8139,7 @@
         </p:nvSpPr>
         <p:spPr>
           <a:xfrm>
-            <a:off x="7714513" y="3086808"/>
+            <a:off x="7315921" y="3086808"/>
             <a:ext cx="1605579" cy="299630"/>
           </a:xfrm>
           <a:prstGeom prst="rect">
@@ -9744,8 +8182,8 @@
         </p:nvSpPr>
         <p:spPr>
           <a:xfrm>
-            <a:off x="7714513" y="3366706"/>
-            <a:ext cx="1605579" cy="638184"/>
+            <a:off x="7315921" y="3366706"/>
+            <a:ext cx="1605579" cy="515073"/>
           </a:xfrm>
           <a:prstGeom prst="rect">
             <a:avLst/>
@@ -9767,7 +8205,7 @@
                 <a:latin typeface="Times New Roman" panose="02020603050405020304" pitchFamily="18" charset="0"/>
                 <a:cs typeface="Times New Roman" panose="02020603050405020304" pitchFamily="18" charset="0"/>
               </a:rPr>
-              <a:t>FZS-supported technical assistance strengthened infrastructure, management capacity, and operational presence around Lusinga and the accessible Plateau core.</a:t>
+              <a:t>FZS-supported technical assistance strengthened infrastructure, management capacity, and operational presence on the Plateau.</a:t>
             </a:r>
             <a:endParaRPr sz="800" dirty="0">
               <a:solidFill>
@@ -9787,7 +8225,7 @@
         </p:nvSpPr>
         <p:spPr>
           <a:xfrm>
-            <a:off x="7714513" y="4195920"/>
+            <a:off x="7315921" y="4195920"/>
             <a:ext cx="1605579" cy="299630"/>
           </a:xfrm>
           <a:prstGeom prst="rect">
@@ -9830,7 +8268,7 @@
         </p:nvSpPr>
         <p:spPr>
           <a:xfrm>
-            <a:off x="7714513" y="4475819"/>
+            <a:off x="7315921" y="4475819"/>
             <a:ext cx="1605579" cy="515073"/>
           </a:xfrm>
           <a:prstGeom prst="rect">
@@ -9853,7 +8291,7 @@
                 <a:latin typeface="Times New Roman" panose="02020603050405020304" pitchFamily="18" charset="0"/>
                 <a:cs typeface="Times New Roman" panose="02020603050405020304" pitchFamily="18" charset="0"/>
               </a:rPr>
-              <a:t>Renewed attacks, displacement, and abandonment of park positions contracted operational reach across the Plateau.</a:t>
+              <a:t>Renewed militia attacks, population displacement, and abandonment of park positions contracted operational reach.</a:t>
             </a:r>
             <a:endParaRPr sz="800" dirty="0">
               <a:solidFill>
@@ -9873,7 +8311,7 @@
         </p:nvSpPr>
         <p:spPr>
           <a:xfrm>
-            <a:off x="7714513" y="5214052"/>
+            <a:off x="7315921" y="5214052"/>
             <a:ext cx="1605579" cy="299630"/>
           </a:xfrm>
           <a:prstGeom prst="rect">
@@ -9896,27 +8334,7 @@
                 <a:latin typeface="Times New Roman" panose="02020603050405020304" pitchFamily="18" charset="0"/>
                 <a:cs typeface="Times New Roman" panose="02020603050405020304" pitchFamily="18" charset="0"/>
               </a:rPr>
-              <a:t>2016: Plateau transition to park-</a:t>
-            </a:r>
-            <a:r>
-              <a:rPr lang="en-US" sz="900" b="1" dirty="0" err="1">
-                <a:solidFill>
-                  <a:srgbClr val="111111"/>
-                </a:solidFill>
-                <a:latin typeface="Times New Roman" panose="02020603050405020304" pitchFamily="18" charset="0"/>
-                <a:cs typeface="Times New Roman" panose="02020603050405020304" pitchFamily="18" charset="0"/>
-              </a:rPr>
-              <a:t>centred</a:t>
-            </a:r>
-            <a:r>
-              <a:rPr lang="en-US" sz="900" b="1" dirty="0">
-                <a:solidFill>
-                  <a:srgbClr val="111111"/>
-                </a:solidFill>
-                <a:latin typeface="Times New Roman" panose="02020603050405020304" pitchFamily="18" charset="0"/>
-                <a:cs typeface="Times New Roman" panose="02020603050405020304" pitchFamily="18" charset="0"/>
-              </a:rPr>
-              <a:t> control</a:t>
+              <a:t>2016: Park operations strengthen</a:t>
             </a:r>
             <a:endParaRPr sz="900" b="1" dirty="0">
               <a:solidFill>
@@ -9936,8 +8354,8 @@
         </p:nvSpPr>
         <p:spPr>
           <a:xfrm>
-            <a:off x="7714513" y="5502576"/>
-            <a:ext cx="1605579" cy="638184"/>
+            <a:off x="7315921" y="5502576"/>
+            <a:ext cx="1605579" cy="515073"/>
           </a:xfrm>
           <a:prstGeom prst="rect">
             <a:avLst/>
@@ -9950,7 +8368,6 @@
           </a:bodyPr>
           <a:lstStyle/>
           <a:p>
-            <a:pPr algn="l"/>
             <a:r>
               <a:rPr lang="en-US" sz="800" dirty="0">
                 <a:solidFill>
@@ -9959,7 +8376,7 @@
                 <a:latin typeface="Times New Roman" panose="02020603050405020304" pitchFamily="18" charset="0"/>
                 <a:cs typeface="Times New Roman" panose="02020603050405020304" pitchFamily="18" charset="0"/>
               </a:rPr>
-              <a:t>Renewed systematic patrols, </a:t>
+              <a:t>The arrival of warden Rodrigue </a:t>
             </a:r>
             <a:r>
               <a:rPr lang="en-US" sz="800" dirty="0" err="1">
@@ -9969,7 +8386,7 @@
                 <a:latin typeface="Times New Roman" panose="02020603050405020304" pitchFamily="18" charset="0"/>
                 <a:cs typeface="Times New Roman" panose="02020603050405020304" pitchFamily="18" charset="0"/>
               </a:rPr>
-              <a:t>organisational</a:t>
+              <a:t>Katembo</a:t>
             </a:r>
             <a:r>
               <a:rPr lang="en-US" sz="800" dirty="0">
@@ -9979,7 +8396,7 @@
                 <a:latin typeface="Times New Roman" panose="02020603050405020304" pitchFamily="18" charset="0"/>
                 <a:cs typeface="Times New Roman" panose="02020603050405020304" pitchFamily="18" charset="0"/>
               </a:rPr>
-              <a:t> strengthening, and Gédéon’s surrender preceded the formal public–private management partnership.</a:t>
+              <a:t>, international support, and warlord Gédéon’s surrender led to strengthening of the park authorities.</a:t>
             </a:r>
             <a:endParaRPr sz="800" dirty="0">
               <a:solidFill>
@@ -10068,7 +8485,7 @@
         </p:nvSpPr>
         <p:spPr>
           <a:xfrm>
-            <a:off x="6256254" y="1945658"/>
+            <a:off x="5857662" y="1945658"/>
             <a:ext cx="1318634" cy="161130"/>
           </a:xfrm>
           <a:prstGeom prst="rect">
@@ -10137,7 +8554,7 @@
         </p:nvSpPr>
         <p:spPr>
           <a:xfrm>
-            <a:off x="6256254" y="2786218"/>
+            <a:off x="5857662" y="2786218"/>
             <a:ext cx="1318634" cy="161130"/>
           </a:xfrm>
           <a:prstGeom prst="rect">
@@ -10186,7 +8603,7 @@
         </p:nvSpPr>
         <p:spPr>
           <a:xfrm>
-            <a:off x="6291971" y="3477965"/>
+            <a:off x="5893379" y="3477965"/>
             <a:ext cx="1318634" cy="161130"/>
           </a:xfrm>
           <a:prstGeom prst="rect">
@@ -10255,7 +8672,7 @@
         </p:nvSpPr>
         <p:spPr>
           <a:xfrm>
-            <a:off x="6250463" y="4097306"/>
+            <a:off x="5851871" y="4097306"/>
             <a:ext cx="1318634" cy="161130"/>
           </a:xfrm>
           <a:prstGeom prst="rect">
@@ -10324,7 +8741,7 @@
         </p:nvSpPr>
         <p:spPr>
           <a:xfrm>
-            <a:off x="6250463" y="5237128"/>
+            <a:off x="5851871" y="5237128"/>
             <a:ext cx="1318634" cy="161130"/>
           </a:xfrm>
           <a:prstGeom prst="rect">
@@ -10393,7 +8810,7 @@
         </p:nvSpPr>
         <p:spPr>
           <a:xfrm>
-            <a:off x="6256254" y="1236751"/>
+            <a:off x="5857662" y="1236751"/>
             <a:ext cx="1318634" cy="161130"/>
           </a:xfrm>
           <a:prstGeom prst="rect">

</xml_diff>